<commit_message>
Put the thesis and strategy slides into the note deck in the team template
The one-page thesis and the strategy slide (allocation + risk/return) are built by their own
builders and scaled onto the 16:9 note deck as slides 3-4; note slides renumbered 5-10,
agenda updated. Thesis titles match the team's final edits.

Co-Authored-By: Claude Opus 5.5 <noreply@anthropic.com>
Claude-Session: https://claude.ai/code/session_01Rwoh8cFDQqLD8JWT3mee6y
</commit_message>
<xml_diff>
--- a/deck/Investment-Thesis-OnePage.pptx
+++ b/deck/Investment-Thesis-OnePage.pptx
@@ -1218,7 +1218,7 @@
                 <a:ea typeface="Arial" pitchFamily="34" charset="-122"/>
                 <a:cs typeface="Arial" pitchFamily="34" charset="-120"/>
               </a:rPr>
-              <a:t>Investment thesis: Asia owns AI's hardware, and 2026's market rewards an autocall</a:t>
+              <a:t>Investment thesis: Monopolizing the AI Supply Chain via Structured Overlays</a:t>
             </a:r>
             <a:endParaRPr lang="en-US" sz="2200" dirty="0"/>
           </a:p>
@@ -1523,7 +1523,7 @@
                 <a:ea typeface="Arial" pitchFamily="34" charset="-122"/>
                 <a:cs typeface="Arial" pitchFamily="34" charset="-120"/>
               </a:rPr>
-              <a:t>What we own: Asia controls AI's hardware bottlenecks</a:t>
+              <a:t>Asia controls AI's hardware bottlenecks</a:t>
             </a:r>
             <a:endParaRPr lang="en-US" sz="1250" dirty="0"/>
           </a:p>
@@ -2185,7 +2185,7 @@
                 <a:ea typeface="Arial" pitchFamily="34" charset="-122"/>
                 <a:cs typeface="Arial" pitchFamily="34" charset="-120"/>
               </a:rPr>
-              <a:t>Why an autocall now: 2026 punishes bonds and buy-and-hold</a:t>
+              <a:t>2026 punishes bonds and buy-and-hold</a:t>
             </a:r>
             <a:endParaRPr lang="en-US" sz="1250" dirty="0"/>
           </a:p>

</xml_diff>